<commit_message>
docs(submission): correct exhibitor affiliation
</commit_message>
<xml_diff>
--- a/output/presentation/digital-delta-innovation-fair.pptx
+++ b/output/presentation/digital-delta-innovation-fair.pptx
@@ -4133,7 +4133,7 @@
         <p:spPr>
           <a:xfrm>
             <a:off x="566928" y="777240"/>
-            <a:ext cx="4983480" cy="320040"/>
+            <a:ext cx="5257800" cy="320040"/>
           </a:xfrm>
           <a:prstGeom prst="rect">
             <a:avLst/>
@@ -4152,13 +4152,13 @@
               </a:spcAft>
             </a:pPr>
             <a:r>
-              <a:rPr sz="1200" b="1" i="0">
+              <a:rPr sz="1050" b="1" i="0">
                 <a:solidFill>
                   <a:srgbClr val="1EB8BC"/>
                 </a:solidFill>
                 <a:latin typeface="Aptos"/>
               </a:rPr>
-              <a:t>BANGLADESH INNOVATION FAIR 2026</a:t>
+              <a:t>BANGLADESH INNOVATION FAIR 2026  •  INNOVATION EXHIBITOR</a:t>
             </a:r>
           </a:p>
         </p:txBody>
@@ -4344,7 +4344,7 @@
         <p:spPr>
           <a:xfrm>
             <a:off x="566928" y="6071616"/>
-            <a:ext cx="5029200" cy="256032"/>
+            <a:ext cx="5303520" cy="256032"/>
           </a:xfrm>
           <a:prstGeom prst="rect">
             <a:avLst/>
@@ -4369,7 +4369,7 @@
                 </a:solidFill>
                 <a:latin typeface="Aptos"/>
               </a:rPr>
-              <a:t>Touhidul Alam Seyam  •  Individual project lead and developer</a:t>
+              <a:t>Touhidul Alam Seyam  •  BGC Trust University Bangladesh</a:t>
             </a:r>
           </a:p>
         </p:txBody>
@@ -13004,7 +13004,46 @@
         </p:nvSpPr>
         <p:spPr>
           <a:xfrm>
-            <a:off x="9308592" y="3273552"/>
+            <a:off x="9308592" y="3090672"/>
+            <a:ext cx="1828800" cy="347472"/>
+          </a:xfrm>
+          <a:prstGeom prst="rect">
+            <a:avLst/>
+          </a:prstGeom>
+          <a:noFill/>
+        </p:spPr>
+        <p:txBody>
+          <a:bodyPr wrap="square" lIns="0" rIns="0" tIns="0" bIns="0" anchor="t">
+            <a:spAutoFit/>
+          </a:bodyPr>
+          <a:lstStyle/>
+          <a:p>
+            <a:pPr algn="l">
+              <a:spcAft>
+                <a:spcPts val="0"/>
+              </a:spcAft>
+            </a:pPr>
+            <a:r>
+              <a:rPr sz="950" b="1" i="0">
+                <a:solidFill>
+                  <a:srgbClr val="087F8C"/>
+                </a:solidFill>
+                <a:latin typeface="Aptos"/>
+              </a:rPr>
+              <a:t>BGC Trust University Bangladesh</a:t>
+            </a:r>
+          </a:p>
+        </p:txBody>
+      </p:sp>
+      <p:sp>
+        <p:nvSpPr>
+          <p:cNvPr id="16" name="TextBox 15"/>
+          <p:cNvSpPr txBox="1"/>
+          <p:nvPr/>
+        </p:nvSpPr>
+        <p:spPr>
+          <a:xfrm>
+            <a:off x="9308592" y="3493008"/>
             <a:ext cx="1828800" cy="1033271"/>
           </a:xfrm>
           <a:prstGeom prst="rect">
@@ -13039,7 +13078,7 @@
       </p:sp>
       <p:sp>
         <p:nvSpPr>
-          <p:cNvPr id="16" name="TextBox 15"/>
+          <p:cNvPr id="17" name="TextBox 16"/>
           <p:cNvSpPr txBox="1"/>
           <p:nvPr/>
         </p:nvSpPr>
@@ -13078,7 +13117,7 @@
       </p:sp>
       <p:sp>
         <p:nvSpPr>
-          <p:cNvPr id="17" name="TextBox 16"/>
+          <p:cNvPr id="18" name="TextBox 17"/>
           <p:cNvSpPr txBox="1"/>
           <p:nvPr/>
         </p:nvSpPr>
@@ -13117,7 +13156,7 @@
       </p:sp>
       <p:sp>
         <p:nvSpPr>
-          <p:cNvPr id="18" name="TextBox 17"/>
+          <p:cNvPr id="19" name="TextBox 18"/>
           <p:cNvSpPr txBox="1"/>
           <p:nvPr/>
         </p:nvSpPr>
@@ -13156,7 +13195,7 @@
       </p:sp>
       <p:sp>
         <p:nvSpPr>
-          <p:cNvPr id="19" name="TextBox 18"/>
+          <p:cNvPr id="20" name="TextBox 19"/>
           <p:cNvSpPr txBox="1"/>
           <p:nvPr/>
         </p:nvSpPr>
@@ -13195,7 +13234,7 @@
       </p:sp>
       <p:sp>
         <p:nvSpPr>
-          <p:cNvPr id="20" name="TextBox 19"/>
+          <p:cNvPr id="21" name="TextBox 20"/>
           <p:cNvSpPr txBox="1"/>
           <p:nvPr/>
         </p:nvSpPr>
@@ -13234,7 +13273,7 @@
       </p:sp>
       <p:sp>
         <p:nvSpPr>
-          <p:cNvPr id="21" name="TextBox 20"/>
+          <p:cNvPr id="22" name="TextBox 21"/>
           <p:cNvSpPr txBox="1"/>
           <p:nvPr/>
         </p:nvSpPr>

</xml_diff>